<commit_message>
Correct catalog, correct font and version for global
</commit_message>
<xml_diff>
--- a/slides/slide_01.pptx
+++ b/slides/slide_01.pptx
@@ -26,61 +26,38 @@
       <p:bold r:id="rId9"/>
     </p:embeddedFont>
     <p:embeddedFont>
-      <p:font typeface="Bebas Neue" panose="020B0606020202050201" pitchFamily="2" charset="0"/>
+      <p:font typeface="Hanken Grotesk" panose="020B0604020202020204" charset="0"/>
       <p:regular r:id="rId10"/>
-    </p:embeddedFont>
-    <p:embeddedFont>
-      <p:font typeface="DM Mono" panose="020B0509040201040103" pitchFamily="1" charset="0"/>
-      <p:regular r:id="rId11"/>
+      <p:bold r:id="rId11"/>
       <p:italic r:id="rId12"/>
-    </p:embeddedFont>
-    <p:embeddedFont>
-      <p:font typeface="Hanken Grotesk" panose="020B0604020202020204" charset="0"/>
-      <p:regular r:id="rId13"/>
-      <p:bold r:id="rId14"/>
-      <p:italic r:id="rId15"/>
-      <p:boldItalic r:id="rId16"/>
-    </p:embeddedFont>
-    <p:embeddedFont>
-      <p:font typeface="Open Sans" panose="020B0606030504020204" pitchFamily="2" charset="0"/>
-      <p:regular r:id="rId17"/>
-      <p:bold r:id="rId18"/>
-      <p:italic r:id="rId19"/>
-      <p:boldItalic r:id="rId20"/>
+      <p:boldItalic r:id="rId13"/>
     </p:embeddedFont>
     <p:embeddedFont>
       <p:font typeface="Raleway" pitchFamily="2" charset="0"/>
-      <p:regular r:id="rId21"/>
-      <p:bold r:id="rId22"/>
-      <p:italic r:id="rId23"/>
-      <p:boldItalic r:id="rId24"/>
+      <p:regular r:id="rId14"/>
+      <p:bold r:id="rId15"/>
+      <p:italic r:id="rId16"/>
+      <p:boldItalic r:id="rId17"/>
     </p:embeddedFont>
     <p:embeddedFont>
       <p:font typeface="Raleway Black" pitchFamily="2" charset="0"/>
-      <p:bold r:id="rId25"/>
-      <p:boldItalic r:id="rId26"/>
+      <p:bold r:id="rId18"/>
+      <p:boldItalic r:id="rId19"/>
     </p:embeddedFont>
     <p:embeddedFont>
       <p:font typeface="Raleway ExtraBold" pitchFamily="2" charset="0"/>
-      <p:bold r:id="rId27"/>
-      <p:boldItalic r:id="rId28"/>
+      <p:bold r:id="rId20"/>
+      <p:boldItalic r:id="rId21"/>
     </p:embeddedFont>
     <p:embeddedFont>
       <p:font typeface="Roboto Medium" panose="02000000000000000000" pitchFamily="2" charset="0"/>
-      <p:regular r:id="rId29"/>
-      <p:italic r:id="rId30"/>
+      <p:regular r:id="rId22"/>
+      <p:italic r:id="rId23"/>
     </p:embeddedFont>
     <p:embeddedFont>
       <p:font typeface="Roboto" panose="02000000000000000000" pitchFamily="2"/>
-      <p:bold r:id="rId31"/>
-      <p:boldItalic r:id="rId32"/>
-    </p:embeddedFont>
-    <p:embeddedFont>
-      <p:font typeface="Segoe UI" panose="020B0502040204020203" pitchFamily="2" charset="0"/>
-      <p:regular r:id="rId33"/>
-      <p:bold r:id="rId34"/>
-      <p:italic r:id="rId35"/>
-      <p:boldItalic r:id="rId36"/>
+      <p:bold r:id="rId24"/>
+      <p:boldItalic r:id="rId25"/>
     </p:embeddedFont>
   </p:embeddedFontLst>
   <p:custDataLst>
@@ -884,7 +861,7 @@
           <a:bodyPr/>
           <a:lstStyle/>
           <a:p>
-            <a:fld id="{94C5A100-EBEB-4496-82F2-E146BB5063E8}" type="datetimeFigureOut">
+            <a:fld id="{9D8C2100-466E-4BD4-B58F-E35E71E91353}" type="datetimeFigureOut">
               <a:rPr lang="en-US" smtClean="0"/>
               <a:t>11/7/2009</a:t>
             </a:fld>
@@ -1048,7 +1025,7 @@
           <a:bodyPr/>
           <a:lstStyle/>
           <a:p>
-            <a:fld id="{23A192E0-A672-4031-8870-B96A8B482BD8}" type="datetimeFigureOut">
+            <a:fld id="{BCAC2EC2-DDEB-4730-BD9D-B124B67A41E7}" type="datetimeFigureOut">
               <a:rPr lang="en-US" smtClean="0"/>
               <a:t>11/7/2009</a:t>
             </a:fld>
@@ -1212,7 +1189,7 @@
           <a:bodyPr/>
           <a:lstStyle/>
           <a:p>
-            <a:fld id="{9FFF1F6C-DB04-491C-B0C5-25D954D26570}" type="datetimeFigureOut">
+            <a:fld id="{3545F728-62AF-4567-830D-07EAA2646A15}" type="datetimeFigureOut">
               <a:rPr lang="en-US" smtClean="0"/>
               <a:t>11/7/2009</a:t>
             </a:fld>
@@ -13117,7 +13094,7 @@
           <a:bodyPr/>
           <a:lstStyle/>
           <a:p>
-            <a:fld id="{828BEA7F-C857-4F5A-BA61-1461D96790AF}" type="datetimeFigureOut">
+            <a:fld id="{5701CC4A-3995-4F23-83DD-31C330CAE769}" type="datetimeFigureOut">
               <a:rPr lang="en-US" smtClean="0"/>
               <a:t>11/7/2009</a:t>
             </a:fld>
@@ -33218,7 +33195,7 @@
           <a:bodyPr/>
           <a:lstStyle/>
           <a:p>
-            <a:fld id="{AE382611-9C9F-4629-8D03-6AE4A1A96558}" type="datetimeFigureOut">
+            <a:fld id="{F686EEED-8D8A-4680-AA0A-095B0F836B37}" type="datetimeFigureOut">
               <a:rPr lang="en-US" smtClean="0"/>
               <a:t>11/7/2009</a:t>
             </a:fld>
@@ -38865,7 +38842,7 @@
           <a:bodyPr/>
           <a:lstStyle/>
           <a:p>
-            <a:fld id="{61B5C810-E379-4E4E-855B-4BB2613A0A8D}" type="datetimeFigureOut">
+            <a:fld id="{A70E3005-2241-4E7C-AD49-D795A0E09E05}" type="datetimeFigureOut">
               <a:rPr lang="en-US" smtClean="0"/>
               <a:t>11/7/2009</a:t>
             </a:fld>
@@ -39254,7 +39231,7 @@
           <a:bodyPr/>
           <a:lstStyle/>
           <a:p>
-            <a:fld id="{41FC2D84-C95C-4AE9-90A7-6E394362B28E}" type="datetimeFigureOut">
+            <a:fld id="{47ADA9B6-8766-4812-A22B-2BD731BC7C3A}" type="datetimeFigureOut">
               <a:rPr lang="en-US" smtClean="0"/>
               <a:t>11/7/2009</a:t>
             </a:fld>
@@ -39367,7 +39344,7 @@
           <a:bodyPr/>
           <a:lstStyle/>
           <a:p>
-            <a:fld id="{ED9C2583-63DE-46BB-87B4-5CE978888FC7}" type="datetimeFigureOut">
+            <a:fld id="{433840F9-3B31-4D28-B25F-6C4764758918}" type="datetimeFigureOut">
               <a:rPr lang="en-US" smtClean="0"/>
               <a:t>11/7/2009</a:t>
             </a:fld>
@@ -39457,7 +39434,7 @@
           <a:bodyPr/>
           <a:lstStyle/>
           <a:p>
-            <a:fld id="{EB123E56-BAF7-482E-BEE7-C321D6BFD158}" type="datetimeFigureOut">
+            <a:fld id="{D7D44D10-4062-4973-A3FD-25E57807D1AB}" type="datetimeFigureOut">
               <a:rPr lang="en-US" smtClean="0"/>
               <a:t>11/7/2009</a:t>
             </a:fld>
@@ -39712,7 +39689,7 @@
           <a:bodyPr/>
           <a:lstStyle/>
           <a:p>
-            <a:fld id="{9B14BCE3-4547-4815-B5AD-EFFB5DADD6AE}" type="datetimeFigureOut">
+            <a:fld id="{E54DB88F-561E-4F4C-A4A3-874A3287B890}" type="datetimeFigureOut">
               <a:rPr lang="en-US" smtClean="0"/>
               <a:t>11/7/2009</a:t>
             </a:fld>
@@ -39944,7 +39921,7 @@
           <a:bodyPr/>
           <a:lstStyle/>
           <a:p>
-            <a:fld id="{622FB096-4E70-4142-B35C-A80CDA04832A}" type="datetimeFigureOut">
+            <a:fld id="{192EFF80-C689-4230-B3F9-3A23A6EDAAB2}" type="datetimeFigureOut">
               <a:rPr lang="en-US" smtClean="0"/>
               <a:t>11/7/2009</a:t>
             </a:fld>
@@ -41812,10 +41789,16 @@
           <a:lstStyle/>
           <a:p>
             <a:r>
-              <a:rPr lang="en"/>
+              <a:rPr lang="en" b="1">
+                <a:latin typeface="Arial"/>
+                <a:cs typeface="Arial"/>
+              </a:rPr>
               <a:t>[ТЕМА ДОКЛАДА ИЛИ НАЗВАНИЕ ПРОЕКТА]</a:t>
             </a:r>
-            <a:endParaRPr lang="ru-RU"/>
+            <a:endParaRPr lang="ru-RU" b="1">
+              <a:latin typeface="Arial"/>
+              <a:cs typeface="Arial"/>
+            </a:endParaRPr>
           </a:p>
         </p:txBody>
       </p:sp>
@@ -41847,9 +41830,19 @@
             <a:pPr marL="0" indent="0"/>
             <a:r>
               <a:rPr lang="en"/>
-              <a:t>[Краткое описание сути проекта, имя докладчика или название департамента]</a:t>
+              <a:t>[</a:t>
             </a:r>
-            <a:endParaRPr lang="ru-RU"/>
+            <a:r>
+              <a:rPr lang="en" err="1">
+                <a:latin typeface="Arial"/>
+                <a:cs typeface="Arial"/>
+              </a:rPr>
+              <a:t>Краткое описание сути проекта, имя докладчика или название департамента]</a:t>
+            </a:r>
+            <a:endParaRPr lang="ru-RU">
+              <a:latin typeface="Arial"/>
+              <a:cs typeface="Arial"/>
+            </a:endParaRPr>
           </a:p>
           <a:p>
             <a:pPr marL="0" indent="0"/>

</xml_diff>

<commit_message>
Correct manifest and correct icons
</commit_message>
<xml_diff>
--- a/slides/slide_01.pptx
+++ b/slides/slide_01.pptx
@@ -861,7 +861,7 @@
           <a:bodyPr/>
           <a:lstStyle/>
           <a:p>
-            <a:fld id="{9D8C2100-466E-4BD4-B58F-E35E71E91353}" type="datetimeFigureOut">
+            <a:fld id="{3CF16D08-79F6-487B-863C-B5B072E31ACE}" type="datetimeFigureOut">
               <a:rPr lang="en-US" smtClean="0"/>
               <a:t>11/7/2009</a:t>
             </a:fld>
@@ -1025,7 +1025,7 @@
           <a:bodyPr/>
           <a:lstStyle/>
           <a:p>
-            <a:fld id="{BCAC2EC2-DDEB-4730-BD9D-B124B67A41E7}" type="datetimeFigureOut">
+            <a:fld id="{4B865F14-F733-4378-9874-B4E479CFBE75}" type="datetimeFigureOut">
               <a:rPr lang="en-US" smtClean="0"/>
               <a:t>11/7/2009</a:t>
             </a:fld>
@@ -1189,7 +1189,7 @@
           <a:bodyPr/>
           <a:lstStyle/>
           <a:p>
-            <a:fld id="{3545F728-62AF-4567-830D-07EAA2646A15}" type="datetimeFigureOut">
+            <a:fld id="{69DBCB47-4E52-44CD-B524-541FE416D322}" type="datetimeFigureOut">
               <a:rPr lang="en-US" smtClean="0"/>
               <a:t>11/7/2009</a:t>
             </a:fld>
@@ -13094,7 +13094,7 @@
           <a:bodyPr/>
           <a:lstStyle/>
           <a:p>
-            <a:fld id="{5701CC4A-3995-4F23-83DD-31C330CAE769}" type="datetimeFigureOut">
+            <a:fld id="{9BB7F142-CE52-4510-9442-083F0A7413A2}" type="datetimeFigureOut">
               <a:rPr lang="en-US" smtClean="0"/>
               <a:t>11/7/2009</a:t>
             </a:fld>
@@ -33195,7 +33195,7 @@
           <a:bodyPr/>
           <a:lstStyle/>
           <a:p>
-            <a:fld id="{F686EEED-8D8A-4680-AA0A-095B0F836B37}" type="datetimeFigureOut">
+            <a:fld id="{0B6F0AC2-4A24-4FCF-A9E9-EF611EB4BE4A}" type="datetimeFigureOut">
               <a:rPr lang="en-US" smtClean="0"/>
               <a:t>11/7/2009</a:t>
             </a:fld>
@@ -38842,7 +38842,7 @@
           <a:bodyPr/>
           <a:lstStyle/>
           <a:p>
-            <a:fld id="{A70E3005-2241-4E7C-AD49-D795A0E09E05}" type="datetimeFigureOut">
+            <a:fld id="{37CDE5F3-E7CA-48D8-9C1E-B71B13BBEA2C}" type="datetimeFigureOut">
               <a:rPr lang="en-US" smtClean="0"/>
               <a:t>11/7/2009</a:t>
             </a:fld>
@@ -39231,7 +39231,7 @@
           <a:bodyPr/>
           <a:lstStyle/>
           <a:p>
-            <a:fld id="{47ADA9B6-8766-4812-A22B-2BD731BC7C3A}" type="datetimeFigureOut">
+            <a:fld id="{668D9BF8-461D-4F69-8ACB-2C4C11244946}" type="datetimeFigureOut">
               <a:rPr lang="en-US" smtClean="0"/>
               <a:t>11/7/2009</a:t>
             </a:fld>
@@ -39344,7 +39344,7 @@
           <a:bodyPr/>
           <a:lstStyle/>
           <a:p>
-            <a:fld id="{433840F9-3B31-4D28-B25F-6C4764758918}" type="datetimeFigureOut">
+            <a:fld id="{B0F7F146-8B14-41AE-86F8-D9AB9D6BA397}" type="datetimeFigureOut">
               <a:rPr lang="en-US" smtClean="0"/>
               <a:t>11/7/2009</a:t>
             </a:fld>
@@ -39434,7 +39434,7 @@
           <a:bodyPr/>
           <a:lstStyle/>
           <a:p>
-            <a:fld id="{D7D44D10-4062-4973-A3FD-25E57807D1AB}" type="datetimeFigureOut">
+            <a:fld id="{89447DD2-C716-4F68-A632-EBA28A8B1D4C}" type="datetimeFigureOut">
               <a:rPr lang="en-US" smtClean="0"/>
               <a:t>11/7/2009</a:t>
             </a:fld>
@@ -39689,7 +39689,7 @@
           <a:bodyPr/>
           <a:lstStyle/>
           <a:p>
-            <a:fld id="{E54DB88F-561E-4F4C-A4A3-874A3287B890}" type="datetimeFigureOut">
+            <a:fld id="{9B91B496-C48B-466F-B1E7-EC075682FDCB}" type="datetimeFigureOut">
               <a:rPr lang="en-US" smtClean="0"/>
               <a:t>11/7/2009</a:t>
             </a:fld>
@@ -39921,7 +39921,7 @@
           <a:bodyPr/>
           <a:lstStyle/>
           <a:p>
-            <a:fld id="{192EFF80-C689-4230-B3F9-3A23A6EDAAB2}" type="datetimeFigureOut">
+            <a:fld id="{373E77CA-8BAF-4C7B-B3CE-CCBFC627A0D5}" type="datetimeFigureOut">
               <a:rPr lang="en-US" smtClean="0"/>
               <a:t>11/7/2009</a:t>
             </a:fld>

</xml_diff>